<commit_message>
docs: remove architectural documentation and diagrams from README and add WebGPU presentation slide and McLaren P1 blend files
</commit_message>
<xml_diff>
--- a/Vulkan-Engine.pptx
+++ b/Vulkan-Engine.pptx
@@ -120,31 +120,23 @@
 </p:presentation>
 </file>
 
-<file path=ppt/revisionInfo.xml><?xml version="1.0" encoding="utf-8"?>
-<p1510:revInfo xmlns:a="http://schemas.openxmlformats.org/drawingml/2006/main" xmlns:r="http://schemas.openxmlformats.org/officeDocument/2006/relationships" xmlns:p1510="http://schemas.microsoft.com/office/powerpoint/2015/10/main">
-  <p1510:revLst>
-    <p1510:client id="{25753728-179F-4E78-9FE1-83D61F8D11DC}" v="4" dt="2026-10-02T10:03:55.953"/>
-  </p1510:revLst>
-</p1510:revInfo>
-</file>
-
 <file path=ppt/changesInfos/changesInfo1.xml><?xml version="1.0" encoding="utf-8"?>
 <pc:chgInfo xmlns:a="http://schemas.openxmlformats.org/drawingml/2006/main" xmlns:r="http://schemas.openxmlformats.org/officeDocument/2006/relationships" xmlns:ac="http://schemas.microsoft.com/office/drawing/2013/main/command" xmlns:pc="http://schemas.microsoft.com/office/powerpoint/2013/main/command">
   <pc:docChgLst>
     <pc:chgData name="Tyrion Bao" userId="86a2b12e41226f78" providerId="LiveId" clId="{BE0B2CE4-1428-496C-ACE6-ADB1F60287EC}"/>
     <pc:docChg chg="undo custSel addSld delSld modSld sldOrd">
-      <pc:chgData name="Tyrion Bao" userId="86a2b12e41226f78" providerId="LiveId" clId="{BE0B2CE4-1428-496C-ACE6-ADB1F60287EC}" dt="2026-10-02T10:06:02.850" v="2078" actId="20577"/>
+      <pc:chgData name="Tyrion Bao" userId="86a2b12e41226f78" providerId="LiveId" clId="{BE0B2CE4-1428-496C-ACE6-ADB1F60287EC}" dt="2026-10-08T08:32:24.651" v="2180" actId="1076"/>
       <pc:docMkLst>
         <pc:docMk/>
       </pc:docMkLst>
       <pc:sldChg chg="modSp new mod">
-        <pc:chgData name="Tyrion Bao" userId="86a2b12e41226f78" providerId="LiveId" clId="{BE0B2CE4-1428-496C-ACE6-ADB1F60287EC}" dt="2026-10-02T07:45:07.650" v="260" actId="20577"/>
+        <pc:chgData name="Tyrion Bao" userId="86a2b12e41226f78" providerId="LiveId" clId="{BE0B2CE4-1428-496C-ACE6-ADB1F60287EC}" dt="2026-10-08T08:31:55.931" v="2175" actId="20577"/>
         <pc:sldMkLst>
           <pc:docMk/>
           <pc:sldMk cId="3812720094" sldId="256"/>
         </pc:sldMkLst>
         <pc:spChg chg="mod">
-          <ac:chgData name="Tyrion Bao" userId="86a2b12e41226f78" providerId="LiveId" clId="{BE0B2CE4-1428-496C-ACE6-ADB1F60287EC}" dt="2026-10-02T07:42:17.725" v="62" actId="20577"/>
+          <ac:chgData name="Tyrion Bao" userId="86a2b12e41226f78" providerId="LiveId" clId="{BE0B2CE4-1428-496C-ACE6-ADB1F60287EC}" dt="2026-10-08T08:31:55.931" v="2175" actId="20577"/>
           <ac:spMkLst>
             <pc:docMk/>
             <pc:sldMk cId="3812720094" sldId="256"/>
@@ -152,7 +144,7 @@
           </ac:spMkLst>
         </pc:spChg>
         <pc:spChg chg="mod">
-          <ac:chgData name="Tyrion Bao" userId="86a2b12e41226f78" providerId="LiveId" clId="{BE0B2CE4-1428-496C-ACE6-ADB1F60287EC}" dt="2026-10-02T07:45:07.650" v="260" actId="20577"/>
+          <ac:chgData name="Tyrion Bao" userId="86a2b12e41226f78" providerId="LiveId" clId="{BE0B2CE4-1428-496C-ACE6-ADB1F60287EC}" dt="2026-10-08T08:31:51.793" v="2174" actId="14100"/>
           <ac:spMkLst>
             <pc:docMk/>
             <pc:sldMk cId="3812720094" sldId="256"/>
@@ -160,8 +152,8 @@
           </ac:spMkLst>
         </pc:spChg>
       </pc:sldChg>
-      <pc:sldChg chg="modSp new mod">
-        <pc:chgData name="Tyrion Bao" userId="86a2b12e41226f78" providerId="LiveId" clId="{BE0B2CE4-1428-496C-ACE6-ADB1F60287EC}" dt="2026-10-02T09:57:59.370" v="1746" actId="20577"/>
+      <pc:sldChg chg="addSp delSp modSp new mod">
+        <pc:chgData name="Tyrion Bao" userId="86a2b12e41226f78" providerId="LiveId" clId="{BE0B2CE4-1428-496C-ACE6-ADB1F60287EC}" dt="2026-10-08T08:32:24.651" v="2180" actId="1076"/>
         <pc:sldMkLst>
           <pc:docMk/>
           <pc:sldMk cId="1637792322" sldId="257"/>
@@ -182,6 +174,22 @@
             <ac:spMk id="3" creationId="{4010F9DF-5F23-AAB3-E1EA-5ADEE9B77134}"/>
           </ac:spMkLst>
         </pc:spChg>
+        <pc:picChg chg="add del mod">
+          <ac:chgData name="Tyrion Bao" userId="86a2b12e41226f78" providerId="LiveId" clId="{BE0B2CE4-1428-496C-ACE6-ADB1F60287EC}" dt="2026-10-08T08:21:50.991" v="2173" actId="478"/>
+          <ac:picMkLst>
+            <pc:docMk/>
+            <pc:sldMk cId="1637792322" sldId="257"/>
+            <ac:picMk id="5" creationId="{59F0022F-20A8-AB83-956C-892CB90B7772}"/>
+          </ac:picMkLst>
+        </pc:picChg>
+        <pc:picChg chg="add mod">
+          <ac:chgData name="Tyrion Bao" userId="86a2b12e41226f78" providerId="LiveId" clId="{BE0B2CE4-1428-496C-ACE6-ADB1F60287EC}" dt="2026-10-08T08:32:24.651" v="2180" actId="1076"/>
+          <ac:picMkLst>
+            <pc:docMk/>
+            <pc:sldMk cId="1637792322" sldId="257"/>
+            <ac:picMk id="7" creationId="{276E3B66-26FF-AD36-908C-F3F6ECA2261E}"/>
+          </ac:picMkLst>
+        </pc:picChg>
       </pc:sldChg>
       <pc:sldChg chg="modSp new mod">
         <pc:chgData name="Tyrion Bao" userId="86a2b12e41226f78" providerId="LiveId" clId="{BE0B2CE4-1428-496C-ACE6-ADB1F60287EC}" dt="2026-10-02T07:43:33.165" v="153" actId="20577"/>
@@ -222,13 +230,13 @@
         </pc:spChg>
       </pc:sldChg>
       <pc:sldChg chg="modSp new mod">
-        <pc:chgData name="Tyrion Bao" userId="86a2b12e41226f78" providerId="LiveId" clId="{BE0B2CE4-1428-496C-ACE6-ADB1F60287EC}" dt="2026-10-02T07:43:53.293" v="189" actId="20577"/>
+        <pc:chgData name="Tyrion Bao" userId="86a2b12e41226f78" providerId="LiveId" clId="{BE0B2CE4-1428-496C-ACE6-ADB1F60287EC}" dt="2026-10-08T08:10:25.802" v="2166" actId="20577"/>
         <pc:sldMkLst>
           <pc:docMk/>
           <pc:sldMk cId="1800488566" sldId="260"/>
         </pc:sldMkLst>
         <pc:spChg chg="mod">
-          <ac:chgData name="Tyrion Bao" userId="86a2b12e41226f78" providerId="LiveId" clId="{BE0B2CE4-1428-496C-ACE6-ADB1F60287EC}" dt="2026-10-02T07:43:53.293" v="189" actId="20577"/>
+          <ac:chgData name="Tyrion Bao" userId="86a2b12e41226f78" providerId="LiveId" clId="{BE0B2CE4-1428-496C-ACE6-ADB1F60287EC}" dt="2026-10-08T08:10:25.802" v="2166" actId="20577"/>
           <ac:spMkLst>
             <pc:docMk/>
             <pc:sldMk cId="1800488566" sldId="260"/>
@@ -282,13 +290,6 @@
           </ac:spMkLst>
         </pc:spChg>
       </pc:sldChg>
-      <pc:sldChg chg="new del">
-        <pc:chgData name="Tyrion Bao" userId="86a2b12e41226f78" providerId="LiveId" clId="{BE0B2CE4-1428-496C-ACE6-ADB1F60287EC}" dt="2026-10-02T07:47:55.733" v="561" actId="47"/>
-        <pc:sldMkLst>
-          <pc:docMk/>
-          <pc:sldMk cId="3021130677" sldId="262"/>
-        </pc:sldMkLst>
-      </pc:sldChg>
       <pc:sldChg chg="modSp new mod">
         <pc:chgData name="Tyrion Bao" userId="86a2b12e41226f78" providerId="LiveId" clId="{BE0B2CE4-1428-496C-ACE6-ADB1F60287EC}" dt="2026-10-02T10:04:59.438" v="2000" actId="20577"/>
         <pc:sldMkLst>
@@ -311,13 +312,6 @@
             <ac:spMk id="3" creationId="{76C5F6CF-1048-44CE-5671-5D14C8C22D4E}"/>
           </ac:spMkLst>
         </pc:spChg>
-      </pc:sldChg>
-      <pc:sldChg chg="new del">
-        <pc:chgData name="Tyrion Bao" userId="86a2b12e41226f78" providerId="LiveId" clId="{BE0B2CE4-1428-496C-ACE6-ADB1F60287EC}" dt="2026-10-02T10:05:57.553" v="2063" actId="47"/>
-        <pc:sldMkLst>
-          <pc:docMk/>
-          <pc:sldMk cId="912078732" sldId="264"/>
-        </pc:sldMkLst>
       </pc:sldChg>
       <pc:sldChg chg="modSp new mod">
         <pc:chgData name="Tyrion Bao" userId="86a2b12e41226f78" providerId="LiveId" clId="{BE0B2CE4-1428-496C-ACE6-ADB1F60287EC}" dt="2026-10-02T10:06:02.850" v="2078" actId="20577"/>
@@ -486,7 +480,7 @@
           <a:p>
             <a:fld id="{9B10F84E-4F92-482B-9E59-E7E052490FE2}" type="datetimeFigureOut">
               <a:rPr lang="zh-CN" altLang="en-US" smtClean="0"/>
-              <a:t>2026/10/2</a:t>
+              <a:t>2026/10/8</a:t>
             </a:fld>
             <a:endParaRPr lang="zh-CN" altLang="en-US"/>
           </a:p>
@@ -684,7 +678,7 @@
           <a:p>
             <a:fld id="{9B10F84E-4F92-482B-9E59-E7E052490FE2}" type="datetimeFigureOut">
               <a:rPr lang="zh-CN" altLang="en-US" smtClean="0"/>
-              <a:t>2026/10/2</a:t>
+              <a:t>2026/10/8</a:t>
             </a:fld>
             <a:endParaRPr lang="zh-CN" altLang="en-US"/>
           </a:p>
@@ -892,7 +886,7 @@
           <a:p>
             <a:fld id="{9B10F84E-4F92-482B-9E59-E7E052490FE2}" type="datetimeFigureOut">
               <a:rPr lang="zh-CN" altLang="en-US" smtClean="0"/>
-              <a:t>2026/10/2</a:t>
+              <a:t>2026/10/8</a:t>
             </a:fld>
             <a:endParaRPr lang="zh-CN" altLang="en-US"/>
           </a:p>
@@ -1090,7 +1084,7 @@
           <a:p>
             <a:fld id="{9B10F84E-4F92-482B-9E59-E7E052490FE2}" type="datetimeFigureOut">
               <a:rPr lang="zh-CN" altLang="en-US" smtClean="0"/>
-              <a:t>2026/10/2</a:t>
+              <a:t>2026/10/8</a:t>
             </a:fld>
             <a:endParaRPr lang="zh-CN" altLang="en-US"/>
           </a:p>
@@ -1365,7 +1359,7 @@
           <a:p>
             <a:fld id="{9B10F84E-4F92-482B-9E59-E7E052490FE2}" type="datetimeFigureOut">
               <a:rPr lang="zh-CN" altLang="en-US" smtClean="0"/>
-              <a:t>2026/10/2</a:t>
+              <a:t>2026/10/8</a:t>
             </a:fld>
             <a:endParaRPr lang="zh-CN" altLang="en-US"/>
           </a:p>
@@ -1630,7 +1624,7 @@
           <a:p>
             <a:fld id="{9B10F84E-4F92-482B-9E59-E7E052490FE2}" type="datetimeFigureOut">
               <a:rPr lang="zh-CN" altLang="en-US" smtClean="0"/>
-              <a:t>2026/10/2</a:t>
+              <a:t>2026/10/8</a:t>
             </a:fld>
             <a:endParaRPr lang="zh-CN" altLang="en-US"/>
           </a:p>
@@ -2042,7 +2036,7 @@
           <a:p>
             <a:fld id="{9B10F84E-4F92-482B-9E59-E7E052490FE2}" type="datetimeFigureOut">
               <a:rPr lang="zh-CN" altLang="en-US" smtClean="0"/>
-              <a:t>2026/10/2</a:t>
+              <a:t>2026/10/8</a:t>
             </a:fld>
             <a:endParaRPr lang="zh-CN" altLang="en-US"/>
           </a:p>
@@ -2183,7 +2177,7 @@
           <a:p>
             <a:fld id="{9B10F84E-4F92-482B-9E59-E7E052490FE2}" type="datetimeFigureOut">
               <a:rPr lang="zh-CN" altLang="en-US" smtClean="0"/>
-              <a:t>2026/10/2</a:t>
+              <a:t>2026/10/8</a:t>
             </a:fld>
             <a:endParaRPr lang="zh-CN" altLang="en-US"/>
           </a:p>
@@ -2296,7 +2290,7 @@
           <a:p>
             <a:fld id="{9B10F84E-4F92-482B-9E59-E7E052490FE2}" type="datetimeFigureOut">
               <a:rPr lang="zh-CN" altLang="en-US" smtClean="0"/>
-              <a:t>2026/10/2</a:t>
+              <a:t>2026/10/8</a:t>
             </a:fld>
             <a:endParaRPr lang="zh-CN" altLang="en-US"/>
           </a:p>
@@ -2607,7 +2601,7 @@
           <a:p>
             <a:fld id="{9B10F84E-4F92-482B-9E59-E7E052490FE2}" type="datetimeFigureOut">
               <a:rPr lang="zh-CN" altLang="en-US" smtClean="0"/>
-              <a:t>2026/10/2</a:t>
+              <a:t>2026/10/8</a:t>
             </a:fld>
             <a:endParaRPr lang="zh-CN" altLang="en-US"/>
           </a:p>
@@ -2895,7 +2889,7 @@
           <a:p>
             <a:fld id="{9B10F84E-4F92-482B-9E59-E7E052490FE2}" type="datetimeFigureOut">
               <a:rPr lang="zh-CN" altLang="en-US" smtClean="0"/>
-              <a:t>2026/10/2</a:t>
+              <a:t>2026/10/8</a:t>
             </a:fld>
             <a:endParaRPr lang="zh-CN" altLang="en-US"/>
           </a:p>
@@ -3136,7 +3130,7 @@
           <a:p>
             <a:fld id="{9B10F84E-4F92-482B-9E59-E7E052490FE2}" type="datetimeFigureOut">
               <a:rPr lang="zh-CN" altLang="en-US" smtClean="0"/>
-              <a:t>2026/10/2</a:t>
+              <a:t>2026/10/8</a:t>
             </a:fld>
             <a:endParaRPr lang="zh-CN" altLang="en-US"/>
           </a:p>
@@ -3571,19 +3565,40 @@
         </p:nvSpPr>
         <p:spPr/>
         <p:txBody>
-          <a:bodyPr/>
-          <a:lstStyle/>
-          <a:p>
+          <a:bodyPr>
+            <a:normAutofit fontScale="90000"/>
+          </a:bodyPr>
+          <a:lstStyle/>
+          <a:p>
+            <a:r>
+              <a:rPr lang="en-US" altLang="zh-CN" dirty="0" err="1"/>
+              <a:t>WebGPU</a:t>
+            </a:r>
             <a:r>
               <a:rPr lang="en-US" altLang="zh-CN" dirty="0"/>
-              <a:t>Vulkan Engine</a:t>
+              <a:t> Rendering Engine</a:t>
             </a:r>
             <a:br>
               <a:rPr lang="en-US" altLang="zh-CN" dirty="0"/>
             </a:br>
             <a:r>
               <a:rPr lang="en-US" altLang="zh-CN" dirty="0"/>
-              <a:t>Car scene showcase</a:t>
+              <a:t>(</a:t>
+            </a:r>
+            <a:r>
+              <a:rPr lang="en-US" altLang="zh-CN" dirty="0" err="1"/>
+              <a:t>WebGPU</a:t>
+            </a:r>
+            <a:r>
+              <a:rPr lang="en-US" altLang="zh-CN" dirty="0"/>
+              <a:t>-Vulkan-Android)</a:t>
+            </a:r>
+            <a:br>
+              <a:rPr lang="en-US" altLang="zh-CN" dirty="0"/>
+            </a:br>
+            <a:r>
+              <a:rPr lang="en-US" altLang="zh-CN" dirty="0"/>
+              <a:t>Car rendering showcase</a:t>
             </a:r>
             <a:endParaRPr lang="zh-CN" altLang="en-US" dirty="0"/>
           </a:p>
@@ -3605,7 +3620,12 @@
             <p:ph type="subTitle" idx="1"/>
           </p:nvPr>
         </p:nvSpPr>
-        <p:spPr/>
+        <p:spPr>
+          <a:xfrm>
+            <a:off x="1524000" y="3602038"/>
+            <a:ext cx="9144000" cy="982236"/>
+          </a:xfrm>
+        </p:spPr>
         <p:txBody>
           <a:bodyPr/>
           <a:lstStyle/>
@@ -3681,7 +3701,7 @@
           <a:p>
             <a:r>
               <a:rPr lang="en-US" altLang="zh-CN" dirty="0"/>
-              <a:t>Showcase</a:t>
+              <a:t>Rendering result</a:t>
             </a:r>
             <a:endParaRPr lang="zh-CN" altLang="en-US" dirty="0"/>
           </a:p>
@@ -3796,6 +3816,36 @@
           </a:p>
         </p:txBody>
       </p:sp>
+      <p:pic>
+        <p:nvPicPr>
+          <p:cNvPr id="7" name="图片 6">
+            <a:extLst>
+              <a:ext uri="{FF2B5EF4-FFF2-40B4-BE49-F238E27FC236}">
+                <a16:creationId xmlns:a16="http://schemas.microsoft.com/office/drawing/2014/main" id="{276E3B66-26FF-AD36-908C-F3F6ECA2261E}"/>
+              </a:ext>
+            </a:extLst>
+          </p:cNvPr>
+          <p:cNvPicPr>
+            <a:picLocks noChangeAspect="1"/>
+          </p:cNvPicPr>
+          <p:nvPr/>
+        </p:nvPicPr>
+        <p:blipFill>
+          <a:blip r:embed="rId2"/>
+          <a:stretch>
+            <a:fillRect/>
+          </a:stretch>
+        </p:blipFill>
+        <p:spPr>
+          <a:xfrm>
+            <a:off x="2920157" y="1659928"/>
+            <a:ext cx="6994898" cy="4832947"/>
+          </a:xfrm>
+          <a:prstGeom prst="rect">
+            <a:avLst/>
+          </a:prstGeom>
+        </p:spPr>
+      </p:pic>
     </p:spTree>
     <p:extLst>
       <p:ext uri="{BB962C8B-B14F-4D97-AF65-F5344CB8AC3E}">

</xml_diff>